<commit_message>
Update Chapter 9 presentation
</commit_message>
<xml_diff>
--- a/slides/chapter09_numbers_workshop.pptx
+++ b/slides/chapter09_numbers_workshop.pptx
@@ -456,7 +456,7 @@
             <a:fld id="{1D8BD707-D9CF-40AE-B4C6-C98DA3205C09}" type="datetimeFigureOut">
               <a:rPr lang="en-US" smtClean="0"/>
               <a:pPr/>
-              <a:t>9/4/2026</a:t>
+              <a:t>9/24/2026</a:t>
             </a:fld>
             <a:endParaRPr lang="en-US"/>
           </a:p>
@@ -621,7 +621,7 @@
             <a:fld id="{1D8BD707-D9CF-40AE-B4C6-C98DA3205C09}" type="datetimeFigureOut">
               <a:rPr lang="en-US" smtClean="0"/>
               <a:pPr/>
-              <a:t>9/4/2026</a:t>
+              <a:t>9/24/2026</a:t>
             </a:fld>
             <a:endParaRPr lang="en-US"/>
           </a:p>
@@ -796,7 +796,7 @@
             <a:fld id="{1D8BD707-D9CF-40AE-B4C6-C98DA3205C09}" type="datetimeFigureOut">
               <a:rPr lang="en-US" smtClean="0"/>
               <a:pPr/>
-              <a:t>9/4/2026</a:t>
+              <a:t>9/24/2026</a:t>
             </a:fld>
             <a:endParaRPr lang="en-US"/>
           </a:p>
@@ -961,7 +961,7 @@
             <a:fld id="{1D8BD707-D9CF-40AE-B4C6-C98DA3205C09}" type="datetimeFigureOut">
               <a:rPr lang="en-US" smtClean="0"/>
               <a:pPr/>
-              <a:t>9/4/2026</a:t>
+              <a:t>9/24/2026</a:t>
             </a:fld>
             <a:endParaRPr lang="en-US"/>
           </a:p>
@@ -1203,7 +1203,7 @@
             <a:fld id="{1D8BD707-D9CF-40AE-B4C6-C98DA3205C09}" type="datetimeFigureOut">
               <a:rPr lang="en-US" smtClean="0"/>
               <a:pPr/>
-              <a:t>9/4/2026</a:t>
+              <a:t>9/24/2026</a:t>
             </a:fld>
             <a:endParaRPr lang="en-US"/>
           </a:p>
@@ -1485,7 +1485,7 @@
             <a:fld id="{1D8BD707-D9CF-40AE-B4C6-C98DA3205C09}" type="datetimeFigureOut">
               <a:rPr lang="en-US" smtClean="0"/>
               <a:pPr/>
-              <a:t>9/4/2026</a:t>
+              <a:t>9/24/2026</a:t>
             </a:fld>
             <a:endParaRPr lang="en-US"/>
           </a:p>
@@ -1901,7 +1901,7 @@
             <a:fld id="{1D8BD707-D9CF-40AE-B4C6-C98DA3205C09}" type="datetimeFigureOut">
               <a:rPr lang="en-US" smtClean="0"/>
               <a:pPr/>
-              <a:t>9/4/2026</a:t>
+              <a:t>9/24/2026</a:t>
             </a:fld>
             <a:endParaRPr lang="en-US"/>
           </a:p>
@@ -2015,7 +2015,7 @@
             <a:fld id="{1D8BD707-D9CF-40AE-B4C6-C98DA3205C09}" type="datetimeFigureOut">
               <a:rPr lang="en-US" smtClean="0"/>
               <a:pPr/>
-              <a:t>9/4/2026</a:t>
+              <a:t>9/24/2026</a:t>
             </a:fld>
             <a:endParaRPr lang="en-US"/>
           </a:p>
@@ -2107,7 +2107,7 @@
             <a:fld id="{1D8BD707-D9CF-40AE-B4C6-C98DA3205C09}" type="datetimeFigureOut">
               <a:rPr lang="en-US" smtClean="0"/>
               <a:pPr/>
-              <a:t>9/4/2026</a:t>
+              <a:t>9/24/2026</a:t>
             </a:fld>
             <a:endParaRPr lang="en-US"/>
           </a:p>
@@ -2379,7 +2379,7 @@
             <a:fld id="{1D8BD707-D9CF-40AE-B4C6-C98DA3205C09}" type="datetimeFigureOut">
               <a:rPr lang="en-US" smtClean="0"/>
               <a:pPr/>
-              <a:t>9/4/2026</a:t>
+              <a:t>9/24/2026</a:t>
             </a:fld>
             <a:endParaRPr lang="en-US"/>
           </a:p>
@@ -2628,7 +2628,7 @@
             <a:fld id="{1D8BD707-D9CF-40AE-B4C6-C98DA3205C09}" type="datetimeFigureOut">
               <a:rPr lang="en-US" smtClean="0"/>
               <a:pPr/>
-              <a:t>9/4/2026</a:t>
+              <a:t>9/24/2026</a:t>
             </a:fld>
             <a:endParaRPr lang="en-US"/>
           </a:p>
@@ -2836,7 +2836,7 @@
             <a:fld id="{1D8BD707-D9CF-40AE-B4C6-C98DA3205C09}" type="datetimeFigureOut">
               <a:rPr lang="en-US" smtClean="0"/>
               <a:pPr/>
-              <a:t>9/4/2026</a:t>
+              <a:t>9/24/2026</a:t>
             </a:fld>
             <a:endParaRPr lang="en-US"/>
           </a:p>
@@ -8168,8 +8168,8 @@
         </p:nvSpPr>
         <p:spPr>
           <a:xfrm>
-            <a:off x="1614292" y="3158397"/>
-            <a:ext cx="7817413" cy="4471035"/>
+            <a:off x="1326587" y="2722259"/>
+            <a:ext cx="7817413" cy="6359883"/>
           </a:xfrm>
           <a:prstGeom prst="rect">
             <a:avLst/>
@@ -8187,7 +8187,7 @@
               </a:lnSpc>
             </a:pPr>
             <a:r>
-              <a:rPr lang="en-US" sz="3599">
+              <a:rPr lang="en-US" sz="3599" dirty="0">
                 <a:solidFill>
                   <a:srgbClr val="FFFFFF"/>
                 </a:solidFill>
@@ -8196,7 +8196,7 @@
                 <a:cs typeface="Times New Roman"/>
                 <a:sym typeface="Times New Roman"/>
               </a:rPr>
-              <a:t>from decimal import Decinmal</a:t>
+              <a:t>from decimal import ROUND_HALF_UP</a:t>
             </a:r>
           </a:p>
           <a:p>
@@ -8205,7 +8205,7 @@
                 <a:spcPts val="5039"/>
               </a:lnSpc>
             </a:pPr>
-            <a:endParaRPr lang="en-US" sz="3599">
+            <a:endParaRPr lang="en-US" sz="3599" dirty="0">
               <a:solidFill>
                 <a:srgbClr val="FFFFFF"/>
               </a:solidFill>
@@ -8222,7 +8222,7 @@
               </a:lnSpc>
             </a:pPr>
             <a:r>
-              <a:rPr lang="en-US" sz="3599">
+              <a:rPr lang="en-US" sz="3599" dirty="0">
                 <a:solidFill>
                   <a:srgbClr val="FFFFFF"/>
                 </a:solidFill>
@@ -8231,7 +8231,7 @@
                 <a:cs typeface="Times New Roman"/>
                 <a:sym typeface="Times New Roman"/>
               </a:rPr>
-              <a:t>decimal_balance = Decimal("100.10")</a:t>
+              <a:t>price = Decimal("10.005")</a:t>
             </a:r>
           </a:p>
           <a:p>
@@ -8241,7 +8241,7 @@
               </a:lnSpc>
             </a:pPr>
             <a:r>
-              <a:rPr lang="en-US" sz="3599">
+              <a:rPr lang="en-US" sz="3599" dirty="0" err="1">
                 <a:solidFill>
                   <a:srgbClr val="FFFFFF"/>
                 </a:solidFill>
@@ -8250,7 +8250,43 @@
                 <a:cs typeface="Times New Roman"/>
                 <a:sym typeface="Times New Roman"/>
               </a:rPr>
-              <a:t>decimal_balance += Decimal("100.10")</a:t>
+              <a:t>rounded_price</a:t>
+            </a:r>
+            <a:r>
+              <a:rPr lang="en-US" sz="3599" dirty="0">
+                <a:solidFill>
+                  <a:srgbClr val="FFFFFF"/>
+                </a:solidFill>
+                <a:latin typeface="Times New Roman"/>
+                <a:ea typeface="Times New Roman"/>
+                <a:cs typeface="Times New Roman"/>
+                <a:sym typeface="Times New Roman"/>
+              </a:rPr>
+              <a:t> = </a:t>
+            </a:r>
+            <a:r>
+              <a:rPr lang="en-US" sz="3599" dirty="0" err="1">
+                <a:solidFill>
+                  <a:srgbClr val="FFFFFF"/>
+                </a:solidFill>
+                <a:latin typeface="Times New Roman"/>
+                <a:ea typeface="Times New Roman"/>
+                <a:cs typeface="Times New Roman"/>
+                <a:sym typeface="Times New Roman"/>
+              </a:rPr>
+              <a:t>price.quantize</a:t>
+            </a:r>
+            <a:r>
+              <a:rPr lang="en-US" sz="3599" dirty="0">
+                <a:solidFill>
+                  <a:srgbClr val="FFFFFF"/>
+                </a:solidFill>
+                <a:latin typeface="Times New Roman"/>
+                <a:ea typeface="Times New Roman"/>
+                <a:cs typeface="Times New Roman"/>
+                <a:sym typeface="Times New Roman"/>
+              </a:rPr>
+              <a:t>(</a:t>
             </a:r>
           </a:p>
           <a:p>
@@ -8260,7 +8296,7 @@
               </a:lnSpc>
             </a:pPr>
             <a:r>
-              <a:rPr lang="en-US" sz="3599">
+              <a:rPr lang="en-US" sz="3599" dirty="0">
                 <a:solidFill>
                   <a:srgbClr val="FFFFFF"/>
                 </a:solidFill>
@@ -8269,7 +8305,7 @@
                 <a:cs typeface="Times New Roman"/>
                 <a:sym typeface="Times New Roman"/>
               </a:rPr>
-              <a:t>decimal_balance += Decimal("100.10")</a:t>
+              <a:t>    Decimal("1.00"),</a:t>
             </a:r>
           </a:p>
           <a:p>
@@ -8278,15 +8314,18 @@
                 <a:spcPts val="5039"/>
               </a:lnSpc>
             </a:pPr>
-            <a:endParaRPr lang="en-US" sz="3599">
-              <a:solidFill>
-                <a:srgbClr val="FFFFFF"/>
-              </a:solidFill>
-              <a:latin typeface="Times New Roman"/>
-              <a:ea typeface="Times New Roman"/>
-              <a:cs typeface="Times New Roman"/>
-              <a:sym typeface="Times New Roman"/>
-            </a:endParaRPr>
+            <a:r>
+              <a:rPr lang="en-US" sz="3599" dirty="0">
+                <a:solidFill>
+                  <a:srgbClr val="FFFFFF"/>
+                </a:solidFill>
+                <a:latin typeface="Times New Roman"/>
+                <a:ea typeface="Times New Roman"/>
+                <a:cs typeface="Times New Roman"/>
+                <a:sym typeface="Times New Roman"/>
+              </a:rPr>
+              <a:t>    rounding=ROUND_HALF_UP</a:t>
+            </a:r>
           </a:p>
           <a:p>
             <a:pPr algn="ctr">
@@ -8295,7 +8334,7 @@
               </a:lnSpc>
             </a:pPr>
             <a:r>
-              <a:rPr lang="en-US" sz="3599">
+              <a:rPr lang="en-US" sz="3599" dirty="0">
                 <a:solidFill>
                   <a:srgbClr val="FFFFFF"/>
                 </a:solidFill>
@@ -8304,7 +8343,69 @@
                 <a:cs typeface="Times New Roman"/>
                 <a:sym typeface="Times New Roman"/>
               </a:rPr>
-              <a:t>print(decimal_balance)</a:t>
+              <a:t>)</a:t>
+            </a:r>
+          </a:p>
+          <a:p>
+            <a:pPr algn="ctr">
+              <a:lnSpc>
+                <a:spcPts val="5039"/>
+              </a:lnSpc>
+            </a:pPr>
+            <a:r>
+              <a:rPr lang="en-US" sz="3599" dirty="0">
+                <a:solidFill>
+                  <a:srgbClr val="FFFFFF"/>
+                </a:solidFill>
+                <a:latin typeface="Times New Roman"/>
+                <a:ea typeface="Times New Roman"/>
+                <a:cs typeface="Times New Roman"/>
+                <a:sym typeface="Times New Roman"/>
+              </a:rPr>
+              <a:t>print("Original Decimal =", price)</a:t>
+            </a:r>
+          </a:p>
+          <a:p>
+            <a:pPr algn="ctr">
+              <a:lnSpc>
+                <a:spcPts val="5039"/>
+              </a:lnSpc>
+            </a:pPr>
+            <a:r>
+              <a:rPr lang="en-US" sz="3599" dirty="0">
+                <a:solidFill>
+                  <a:srgbClr val="FFFFFF"/>
+                </a:solidFill>
+                <a:latin typeface="Times New Roman"/>
+                <a:ea typeface="Times New Roman"/>
+                <a:cs typeface="Times New Roman"/>
+                <a:sym typeface="Times New Roman"/>
+              </a:rPr>
+              <a:t>print("Rounded Decimal =", </a:t>
+            </a:r>
+            <a:r>
+              <a:rPr lang="en-US" sz="3599" dirty="0" err="1">
+                <a:solidFill>
+                  <a:srgbClr val="FFFFFF"/>
+                </a:solidFill>
+                <a:latin typeface="Times New Roman"/>
+                <a:ea typeface="Times New Roman"/>
+                <a:cs typeface="Times New Roman"/>
+                <a:sym typeface="Times New Roman"/>
+              </a:rPr>
+              <a:t>rounded_price</a:t>
+            </a:r>
+            <a:r>
+              <a:rPr lang="en-US" sz="3599" dirty="0">
+                <a:solidFill>
+                  <a:srgbClr val="FFFFFF"/>
+                </a:solidFill>
+                <a:latin typeface="Times New Roman"/>
+                <a:ea typeface="Times New Roman"/>
+                <a:cs typeface="Times New Roman"/>
+                <a:sym typeface="Times New Roman"/>
+              </a:rPr>
+              <a:t>)</a:t>
             </a:r>
           </a:p>
         </p:txBody>

</xml_diff>